<commit_message>
fix(ppt): address review findings
- strip trailing page separator before writing speaker notes
- keep wave CSV inputs under ppt/wave so make_waves.py needs no simulator
- define F and note F = 1 in the CPI identity on the performance pages
</commit_message>
<xml_diff>
--- a/ppt/out/课程设计_验收答辩.pptx
+++ b/ppt/out/课程设计_验收答辩.pptx
@@ -540,12 +540,6 @@
               <a:t>时间：约 0.3 分钟。</a:t>
             </a:r>
           </a:p>
-          <a:p/>
-          <a:p>
-            <a:r>
-              <a:t>---</a:t>
-            </a:r>
-          </a:p>
         </p:txBody>
       </p:sp>
       <p:sp>
@@ -616,12 +610,6 @@
               <a:t>时间：约 0.9 分钟。</a:t>
             </a:r>
           </a:p>
-          <a:p/>
-          <a:p>
-            <a:r>
-              <a:t>---</a:t>
-            </a:r>
-          </a:p>
         </p:txBody>
       </p:sp>
       <p:sp>
@@ -692,12 +680,6 @@
               <a:t>时间：约 0.6 分钟。图：前递优先级波形。</a:t>
             </a:r>
           </a:p>
-          <a:p/>
-          <a:p>
-            <a:r>
-              <a:t>---</a:t>
-            </a:r>
-          </a:p>
         </p:txBody>
       </p:sp>
       <p:sp>
@@ -768,12 +750,6 @@
               <a:t>时间：约 0.6 分钟。图：load-use 冻结波形。</a:t>
             </a:r>
           </a:p>
-          <a:p/>
-          <a:p>
-            <a:r>
-              <a:t>---</a:t>
-            </a:r>
-          </a:p>
         </p:txBody>
       </p:sp>
       <p:sp>
@@ -844,12 +820,6 @@
               <a:t>时间：约 0.6 分钟。图：分支冲刷波形。</a:t>
             </a:r>
           </a:p>
-          <a:p/>
-          <a:p>
-            <a:r>
-              <a:t>---</a:t>
-            </a:r>
-          </a:p>
         </p:txBody>
       </p:sp>
       <p:sp>
@@ -920,12 +890,6 @@
               <a:t>时间：约 0.3 分钟。图：五级流水线运行总览波形。</a:t>
             </a:r>
           </a:p>
-          <a:p/>
-          <a:p>
-            <a:r>
-              <a:t>---</a:t>
-            </a:r>
-          </a:p>
         </p:txBody>
       </p:sp>
       <p:sp>
@@ -996,12 +960,6 @@
               <a:t>时间：约 0.1 分钟。</a:t>
             </a:r>
           </a:p>
-          <a:p/>
-          <a:p>
-            <a:r>
-              <a:t>---</a:t>
-            </a:r>
-          </a:p>
         </p:txBody>
       </p:sp>
       <p:sp>
@@ -1072,12 +1030,6 @@
               <a:t>时间：约 0.5 分钟。图：8N1 帧时序图。</a:t>
             </a:r>
           </a:p>
-          <a:p/>
-          <a:p>
-            <a:r>
-              <a:t>---</a:t>
-            </a:r>
-          </a:p>
         </p:txBody>
       </p:sp>
       <p:sp>
@@ -1148,12 +1100,6 @@
               <a:t>时间：约 0.5 分钟。图：发送与接收状态机。</a:t>
             </a:r>
           </a:p>
-          <a:p/>
-          <a:p>
-            <a:r>
-              <a:t>---</a:t>
-            </a:r>
-          </a:p>
         </p:txBody>
       </p:sp>
       <p:sp>
@@ -1224,12 +1170,6 @@
               <a:t>时间：约 0.6 分钟。</a:t>
             </a:r>
           </a:p>
-          <a:p/>
-          <a:p>
-            <a:r>
-              <a:t>---</a:t>
-            </a:r>
-          </a:p>
         </p:txBody>
       </p:sp>
       <p:sp>
@@ -1300,12 +1240,6 @@
               <a:t>时间：约 0.7 分钟。图：地址空间映射图。</a:t>
             </a:r>
           </a:p>
-          <a:p/>
-          <a:p>
-            <a:r>
-              <a:t>---</a:t>
-            </a:r>
-          </a:p>
         </p:txBody>
       </p:sp>
       <p:sp>
@@ -1376,12 +1310,6 @@
               <a:t>时间：约 0.1 分钟。</a:t>
             </a:r>
           </a:p>
-          <a:p/>
-          <a:p>
-            <a:r>
-              <a:t>---</a:t>
-            </a:r>
-          </a:p>
         </p:txBody>
       </p:sp>
       <p:sp>
@@ -1452,12 +1380,6 @@
               <a:t>时间：约 0.5 分钟。图：发送忙碌状态时序图。</a:t>
             </a:r>
           </a:p>
-          <a:p/>
-          <a:p>
-            <a:r>
-              <a:t>---</a:t>
-            </a:r>
-          </a:p>
         </p:txBody>
       </p:sp>
       <p:sp>
@@ -1528,12 +1450,6 @@
               <a:t>时间：约 0.1 分钟。</a:t>
             </a:r>
           </a:p>
-          <a:p/>
-          <a:p>
-            <a:r>
-              <a:t>---</a:t>
-            </a:r>
-          </a:p>
         </p:txBody>
       </p:sp>
       <p:sp>
@@ -1604,12 +1520,6 @@
               <a:t>时间：约 0.7 分钟。图：SoC 装配结构图。</a:t>
             </a:r>
           </a:p>
-          <a:p/>
-          <a:p>
-            <a:r>
-              <a:t>---</a:t>
-            </a:r>
-          </a:p>
         </p:txBody>
       </p:sp>
       <p:sp>
@@ -1680,12 +1590,6 @@
               <a:t>时间：约 0.4 分钟。图：复位同步时序图。</a:t>
             </a:r>
           </a:p>
-          <a:p/>
-          <a:p>
-            <a:r>
-              <a:t>---</a:t>
-            </a:r>
-          </a:p>
         </p:txBody>
       </p:sp>
       <p:sp>
@@ -1756,12 +1660,6 @@
               <a:t>时间：约 0.3 分钟。图：板级引脚图。</a:t>
             </a:r>
           </a:p>
-          <a:p/>
-          <a:p>
-            <a:r>
-              <a:t>---</a:t>
-            </a:r>
-          </a:p>
         </p:txBody>
       </p:sp>
       <p:sp>
@@ -1832,12 +1730,6 @@
               <a:t>时间：约 0.6 分钟。图：console 流程图。</a:t>
             </a:r>
           </a:p>
-          <a:p/>
-          <a:p>
-            <a:r>
-              <a:t>---</a:t>
-            </a:r>
-          </a:p>
         </p:txBody>
       </p:sp>
       <p:sp>
@@ -1908,12 +1800,6 @@
               <a:t>时间：约 0.4 分钟。图：构建与烧录流程图。</a:t>
             </a:r>
           </a:p>
-          <a:p/>
-          <a:p>
-            <a:r>
-              <a:t>---</a:t>
-            </a:r>
-          </a:p>
         </p:txBody>
       </p:sp>
       <p:sp>
@@ -1984,12 +1870,6 @@
               <a:t>时间：约 0.1 分钟。</a:t>
             </a:r>
           </a:p>
-          <a:p/>
-          <a:p>
-            <a:r>
-              <a:t>---</a:t>
-            </a:r>
-          </a:p>
         </p:txBody>
       </p:sp>
       <p:sp>
@@ -2060,12 +1940,6 @@
               <a:t>时间：约 0.9 分钟。图：三层验证结构图。</a:t>
             </a:r>
           </a:p>
-          <a:p/>
-          <a:p>
-            <a:r>
-              <a:t>---</a:t>
-            </a:r>
-          </a:p>
         </p:txBody>
       </p:sp>
       <p:sp>
@@ -2136,12 +2010,6 @@
               <a:t>时间：约 0.3 分钟。</a:t>
             </a:r>
           </a:p>
-          <a:p/>
-          <a:p>
-            <a:r>
-              <a:t>---</a:t>
-            </a:r>
-          </a:p>
         </p:txBody>
       </p:sp>
       <p:sp>
@@ -2212,12 +2080,6 @@
               <a:t>时间：约 0.5 分钟。图：三层结构框图。</a:t>
             </a:r>
           </a:p>
-          <a:p/>
-          <a:p>
-            <a:r>
-              <a:t>---</a:t>
-            </a:r>
-          </a:p>
         </p:txBody>
       </p:sp>
       <p:sp>
@@ -2288,12 +2150,6 @@
               <a:t>时间：约 0.8 分钟。</a:t>
             </a:r>
           </a:p>
-          <a:p/>
-          <a:p>
-            <a:r>
-              <a:t>---</a:t>
-            </a:r>
-          </a:p>
         </p:txBody>
       </p:sp>
       <p:sp>
@@ -2364,12 +2220,6 @@
               <a:t>时间：约 0.8 分钟。数据来源：pipeline/doc/perf_report.md 第 2.2 节。</a:t>
             </a:r>
           </a:p>
-          <a:p/>
-          <a:p>
-            <a:r>
-              <a:t>---</a:t>
-            </a:r>
-          </a:p>
         </p:txBody>
       </p:sp>
       <p:sp>
@@ -2440,12 +2290,6 @@
               <a:t>时间：约 0.9 分钟。数据来源：pipeline/doc/perf_report.md 第 3、4 节。</a:t>
             </a:r>
           </a:p>
-          <a:p/>
-          <a:p>
-            <a:r>
-              <a:t>---</a:t>
-            </a:r>
-          </a:p>
         </p:txBody>
       </p:sp>
       <p:sp>
@@ -2516,12 +2360,6 @@
               <a:t>时间：约 0.1 分钟。</a:t>
             </a:r>
           </a:p>
-          <a:p/>
-          <a:p>
-            <a:r>
-              <a:t>---</a:t>
-            </a:r>
-          </a:p>
         </p:txBody>
       </p:sp>
       <p:sp>
@@ -2592,12 +2430,6 @@
               <a:t>时间：约 0.8 分钟。图：终端日志截图（待补充）。演示前确认串口与板卡连接。</a:t>
             </a:r>
           </a:p>
-          <a:p/>
-          <a:p>
-            <a:r>
-              <a:t>---</a:t>
-            </a:r>
-          </a:p>
         </p:txBody>
       </p:sp>
       <p:sp>
@@ -2668,12 +2500,6 @@
               <a:t>时间：约 0.1 分钟。</a:t>
             </a:r>
           </a:p>
-          <a:p/>
-          <a:p>
-            <a:r>
-              <a:t>---</a:t>
-            </a:r>
-          </a:p>
         </p:txBody>
       </p:sp>
       <p:sp>
@@ -2814,12 +2640,6 @@
               <a:t>时间：约 0.4 分钟。</a:t>
             </a:r>
           </a:p>
-          <a:p/>
-          <a:p>
-            <a:r>
-              <a:t>---</a:t>
-            </a:r>
-          </a:p>
         </p:txBody>
       </p:sp>
       <p:sp>
@@ -2890,12 +2710,6 @@
               <a:t>时间：约 0.5 分钟。图：目录层次图。</a:t>
             </a:r>
           </a:p>
-          <a:p/>
-          <a:p>
-            <a:r>
-              <a:t>---</a:t>
-            </a:r>
-          </a:p>
         </p:txBody>
       </p:sp>
       <p:sp>
@@ -2966,12 +2780,6 @@
               <a:t>时间：约 0.3 分钟。姓名与分工待补充。</a:t>
             </a:r>
           </a:p>
-          <a:p/>
-          <a:p>
-            <a:r>
-              <a:t>---</a:t>
-            </a:r>
-          </a:p>
         </p:txBody>
       </p:sp>
       <p:sp>
@@ -3042,12 +2850,6 @@
               <a:t>时间：约 0.1 分钟。</a:t>
             </a:r>
           </a:p>
-          <a:p/>
-          <a:p>
-            <a:r>
-              <a:t>---</a:t>
-            </a:r>
-          </a:p>
         </p:txBody>
       </p:sp>
       <p:sp>
@@ -3118,12 +2920,6 @@
               <a:t>时间：约 0.7 分钟。图：五级流水线结构框图。</a:t>
             </a:r>
           </a:p>
-          <a:p/>
-          <a:p>
-            <a:r>
-              <a:t>---</a:t>
-            </a:r>
-          </a:p>
         </p:txBody>
       </p:sp>
       <p:sp>
@@ -3192,12 +2988,6 @@
           <a:p>
             <a:r>
               <a:t>时间：约 0.7 分钟。图：指令类别条数柱状图。</a:t>
-            </a:r>
-          </a:p>
-          <a:p/>
-          <a:p>
-            <a:r>
-              <a:t>---</a:t>
             </a:r>
           </a:p>
         </p:txBody>
@@ -13637,7 +13427,7 @@
         <p:spPr>
           <a:xfrm>
             <a:off x="566928" y="1243584"/>
-            <a:ext cx="11057839" cy="2699003"/>
+            <a:ext cx="11057839" cy="2753868"/>
           </a:xfrm>
           <a:prstGeom prst="rect">
             <a:avLst/>
@@ -13772,7 +13562,28 @@
                 <a:ea typeface="Microsoft YaHei"/>
                 <a:cs typeface="Microsoft YaHei"/>
               </a:rPr>
-              <a:t>每档数据满足恒等式 C_total 等于 IC 加 F 减 1 加 L 加 2T，其中 L 是 load-use 冻结周期数，T 是跳转成立次数。</a:t>
+              <a:t>每档数据满足恒等式 C_total 等于 IC 加 F 减 1 加 L 加 2T。</a:t>
+            </a:r>
+          </a:p>
+          <a:p>
+            <a:pPr>
+              <a:lnSpc>
+                <a:spcPct val="130000"/>
+              </a:lnSpc>
+              <a:spcAft>
+                <a:spcPts val="500"/>
+              </a:spcAft>
+            </a:pPr>
+            <a:r>
+              <a:rPr sz="1600" b="0">
+                <a:solidFill>
+                  <a:srgbClr val="222222"/>
+                </a:solidFill>
+                <a:latin typeface="Microsoft YaHei"/>
+                <a:ea typeface="Microsoft YaHei"/>
+                <a:cs typeface="Microsoft YaHei"/>
+              </a:rPr>
+              <a:t>其中 F 是首个真实 EX 槽的沿号，本次测量为 1。L 是 load-use 冻结周期数，T 是跳转成立次数。</a:t>
             </a:r>
           </a:p>
         </p:txBody>

</xml_diff>